<commit_message>
Product Variant Item- Create necessary files
</commit_message>
<xml_diff>
--- a/.lessons/58 Backend Product And Related Features/24 Product Variant Item- Create necessary files/1.pptx
+++ b/.lessons/58 Backend Product And Related Features/24 Product Variant Item- Create necessary files/1.pptx
@@ -5,9 +5,16 @@
     <p:sldMasterId id="2147483648" r:id="rId1"/>
   </p:sldMasterIdLst>
   <p:sldIdLst>
-    <p:sldId id="413" r:id="rId2"/>
-    <p:sldId id="414" r:id="rId3"/>
-    <p:sldId id="400" r:id="rId4"/>
+    <p:sldId id="414" r:id="rId2"/>
+    <p:sldId id="417" r:id="rId3"/>
+    <p:sldId id="413" r:id="rId4"/>
+    <p:sldId id="415" r:id="rId5"/>
+    <p:sldId id="416" r:id="rId6"/>
+    <p:sldId id="418" r:id="rId7"/>
+    <p:sldId id="400" r:id="rId8"/>
+    <p:sldId id="419" r:id="rId9"/>
+    <p:sldId id="420" r:id="rId10"/>
+    <p:sldId id="421" r:id="rId11"/>
   </p:sldIdLst>
   <p:sldSz cx="12192000" cy="6858000"/>
   <p:notesSz cx="6858000" cy="9144000"/>
@@ -261,7 +268,7 @@
           <a:p>
             <a:fld id="{3E102D2E-813C-461C-9963-687A650C48C0}" type="datetimeFigureOut">
               <a:rPr lang="en-US" smtClean="0"/>
-              <a:t>6/26/2025</a:t>
+              <a:t>10/9/2025</a:t>
             </a:fld>
             <a:endParaRPr lang="en-US"/>
           </a:p>
@@ -459,7 +466,7 @@
           <a:p>
             <a:fld id="{3E102D2E-813C-461C-9963-687A650C48C0}" type="datetimeFigureOut">
               <a:rPr lang="en-US" smtClean="0"/>
-              <a:t>6/26/2025</a:t>
+              <a:t>10/9/2025</a:t>
             </a:fld>
             <a:endParaRPr lang="en-US"/>
           </a:p>
@@ -667,7 +674,7 @@
           <a:p>
             <a:fld id="{3E102D2E-813C-461C-9963-687A650C48C0}" type="datetimeFigureOut">
               <a:rPr lang="en-US" smtClean="0"/>
-              <a:t>6/26/2025</a:t>
+              <a:t>10/9/2025</a:t>
             </a:fld>
             <a:endParaRPr lang="en-US"/>
           </a:p>
@@ -865,7 +872,7 @@
           <a:p>
             <a:fld id="{3E102D2E-813C-461C-9963-687A650C48C0}" type="datetimeFigureOut">
               <a:rPr lang="en-US" smtClean="0"/>
-              <a:t>6/26/2025</a:t>
+              <a:t>10/9/2025</a:t>
             </a:fld>
             <a:endParaRPr lang="en-US"/>
           </a:p>
@@ -1140,7 +1147,7 @@
           <a:p>
             <a:fld id="{3E102D2E-813C-461C-9963-687A650C48C0}" type="datetimeFigureOut">
               <a:rPr lang="en-US" smtClean="0"/>
-              <a:t>6/26/2025</a:t>
+              <a:t>10/9/2025</a:t>
             </a:fld>
             <a:endParaRPr lang="en-US"/>
           </a:p>
@@ -1405,7 +1412,7 @@
           <a:p>
             <a:fld id="{3E102D2E-813C-461C-9963-687A650C48C0}" type="datetimeFigureOut">
               <a:rPr lang="en-US" smtClean="0"/>
-              <a:t>6/26/2025</a:t>
+              <a:t>10/9/2025</a:t>
             </a:fld>
             <a:endParaRPr lang="en-US"/>
           </a:p>
@@ -1817,7 +1824,7 @@
           <a:p>
             <a:fld id="{3E102D2E-813C-461C-9963-687A650C48C0}" type="datetimeFigureOut">
               <a:rPr lang="en-US" smtClean="0"/>
-              <a:t>6/26/2025</a:t>
+              <a:t>10/9/2025</a:t>
             </a:fld>
             <a:endParaRPr lang="en-US"/>
           </a:p>
@@ -1958,7 +1965,7 @@
           <a:p>
             <a:fld id="{3E102D2E-813C-461C-9963-687A650C48C0}" type="datetimeFigureOut">
               <a:rPr lang="en-US" smtClean="0"/>
-              <a:t>6/26/2025</a:t>
+              <a:t>10/9/2025</a:t>
             </a:fld>
             <a:endParaRPr lang="en-US"/>
           </a:p>
@@ -2071,7 +2078,7 @@
           <a:p>
             <a:fld id="{3E102D2E-813C-461C-9963-687A650C48C0}" type="datetimeFigureOut">
               <a:rPr lang="en-US" smtClean="0"/>
-              <a:t>6/26/2025</a:t>
+              <a:t>10/9/2025</a:t>
             </a:fld>
             <a:endParaRPr lang="en-US"/>
           </a:p>
@@ -2382,7 +2389,7 @@
           <a:p>
             <a:fld id="{3E102D2E-813C-461C-9963-687A650C48C0}" type="datetimeFigureOut">
               <a:rPr lang="en-US" smtClean="0"/>
-              <a:t>6/26/2025</a:t>
+              <a:t>10/9/2025</a:t>
             </a:fld>
             <a:endParaRPr lang="en-US"/>
           </a:p>
@@ -2670,7 +2677,7 @@
           <a:p>
             <a:fld id="{3E102D2E-813C-461C-9963-687A650C48C0}" type="datetimeFigureOut">
               <a:rPr lang="en-US" smtClean="0"/>
-              <a:t>6/26/2025</a:t>
+              <a:t>10/9/2025</a:t>
             </a:fld>
             <a:endParaRPr lang="en-US"/>
           </a:p>
@@ -2911,7 +2918,7 @@
           <a:p>
             <a:fld id="{3E102D2E-813C-461C-9963-687A650C48C0}" type="datetimeFigureOut">
               <a:rPr lang="en-US" smtClean="0"/>
-              <a:t>6/26/2025</a:t>
+              <a:t>10/9/2025</a:t>
             </a:fld>
             <a:endParaRPr lang="en-US"/>
           </a:p>
@@ -3319,7 +3326,7 @@
         <p:cNvPr id="1" name="">
           <a:extLst>
             <a:ext uri="{FF2B5EF4-FFF2-40B4-BE49-F238E27FC236}">
-              <a16:creationId xmlns:a16="http://schemas.microsoft.com/office/drawing/2014/main" id="{6A435CBA-29A4-BFD2-CEA7-3290D85ED9F8}"/>
+              <a16:creationId xmlns:a16="http://schemas.microsoft.com/office/drawing/2014/main" id="{E0B23C97-7391-808C-8F93-F1A247B54F0E}"/>
             </a:ext>
           </a:extLst>
         </p:cNvPr>
@@ -3334,12 +3341,79 @@
           <a:chExt cx="0" cy="0"/>
         </a:xfrm>
       </p:grpSpPr>
+      <p:pic>
+        <p:nvPicPr>
+          <p:cNvPr id="4" name="Picture 3">
+            <a:extLst>
+              <a:ext uri="{FF2B5EF4-FFF2-40B4-BE49-F238E27FC236}">
+                <a16:creationId xmlns:a16="http://schemas.microsoft.com/office/drawing/2014/main" id="{3E868889-2A3B-038B-1873-508080F4F83B}"/>
+              </a:ext>
+            </a:extLst>
+          </p:cNvPr>
+          <p:cNvPicPr>
+            <a:picLocks noChangeAspect="1"/>
+          </p:cNvPicPr>
+          <p:nvPr/>
+        </p:nvPicPr>
+        <p:blipFill>
+          <a:blip r:embed="rId2"/>
+          <a:srcRect b="39070"/>
+          <a:stretch>
+            <a:fillRect/>
+          </a:stretch>
+        </p:blipFill>
+        <p:spPr>
+          <a:xfrm>
+            <a:off x="418307" y="2482886"/>
+            <a:ext cx="11355385" cy="1892228"/>
+          </a:xfrm>
+          <a:prstGeom prst="rect">
+            <a:avLst/>
+          </a:prstGeom>
+        </p:spPr>
+      </p:pic>
+    </p:spTree>
+    <p:extLst>
+      <p:ext uri="{BB962C8B-B14F-4D97-AF65-F5344CB8AC3E}">
+        <p14:creationId xmlns:p14="http://schemas.microsoft.com/office/powerpoint/2010/main" val="4233252692"/>
+      </p:ext>
+    </p:extLst>
+  </p:cSld>
+  <p:clrMapOvr>
+    <a:masterClrMapping/>
+  </p:clrMapOvr>
+</p:sld>
+</file>
+
+<file path=ppt/slides/slide10.xml><?xml version="1.0" encoding="utf-8"?>
+<p:sld xmlns:a="http://schemas.openxmlformats.org/drawingml/2006/main" xmlns:r="http://schemas.openxmlformats.org/officeDocument/2006/relationships" xmlns:p="http://schemas.openxmlformats.org/presentationml/2006/main">
+  <p:cSld>
+    <p:spTree>
+      <p:nvGrpSpPr>
+        <p:cNvPr id="1" name="">
+          <a:extLst>
+            <a:ext uri="{FF2B5EF4-FFF2-40B4-BE49-F238E27FC236}">
+              <a16:creationId xmlns:a16="http://schemas.microsoft.com/office/drawing/2014/main" id="{F7400297-8013-7331-4BD5-647EEECFE1DE}"/>
+            </a:ext>
+          </a:extLst>
+        </p:cNvPr>
+        <p:cNvGrpSpPr/>
+        <p:nvPr/>
+      </p:nvGrpSpPr>
+      <p:grpSpPr>
+        <a:xfrm>
+          <a:off x="0" y="0"/>
+          <a:ext cx="0" cy="0"/>
+          <a:chOff x="0" y="0"/>
+          <a:chExt cx="0" cy="0"/>
+        </a:xfrm>
+      </p:grpSpPr>
       <p:sp>
         <p:nvSpPr>
           <p:cNvPr id="3" name="TextBox 2">
             <a:extLst>
               <a:ext uri="{FF2B5EF4-FFF2-40B4-BE49-F238E27FC236}">
-                <a16:creationId xmlns:a16="http://schemas.microsoft.com/office/drawing/2014/main" id="{A727ABBC-76D0-B81B-760F-26FC272AF479}"/>
+                <a16:creationId xmlns:a16="http://schemas.microsoft.com/office/drawing/2014/main" id="{64C23C3C-4E11-719E-60D0-2D157BE2FA5F}"/>
               </a:ext>
             </a:extLst>
           </p:cNvPr>
@@ -3387,7 +3461,7 @@
     </p:spTree>
     <p:extLst>
       <p:ext uri="{BB962C8B-B14F-4D97-AF65-F5344CB8AC3E}">
-        <p14:creationId xmlns:p14="http://schemas.microsoft.com/office/powerpoint/2010/main" val="3863838039"/>
+        <p14:creationId xmlns:p14="http://schemas.microsoft.com/office/powerpoint/2010/main" val="2193773251"/>
       </p:ext>
     </p:extLst>
   </p:cSld>
@@ -3405,7 +3479,7 @@
         <p:cNvPr id="1" name="">
           <a:extLst>
             <a:ext uri="{FF2B5EF4-FFF2-40B4-BE49-F238E27FC236}">
-              <a16:creationId xmlns:a16="http://schemas.microsoft.com/office/drawing/2014/main" id="{E0B23C97-7391-808C-8F93-F1A247B54F0E}"/>
+              <a16:creationId xmlns:a16="http://schemas.microsoft.com/office/drawing/2014/main" id="{84A11A67-1FE1-4531-AB26-80EEB8563AE6}"/>
             </a:ext>
           </a:extLst>
         </p:cNvPr>
@@ -3425,7 +3499,7 @@
           <p:cNvPr id="3" name="TextBox 2">
             <a:extLst>
               <a:ext uri="{FF2B5EF4-FFF2-40B4-BE49-F238E27FC236}">
-                <a16:creationId xmlns:a16="http://schemas.microsoft.com/office/drawing/2014/main" id="{D9BA728D-9AF8-6C25-DF35-1494919186BC}"/>
+                <a16:creationId xmlns:a16="http://schemas.microsoft.com/office/drawing/2014/main" id="{775231B5-FF9F-23DD-FC24-8DC4C695A071}"/>
               </a:ext>
             </a:extLst>
           </p:cNvPr>
@@ -3470,10 +3544,40 @@
           </a:p>
         </p:txBody>
       </p:sp>
+      <p:pic>
+        <p:nvPicPr>
+          <p:cNvPr id="4" name="Picture 3">
+            <a:extLst>
+              <a:ext uri="{FF2B5EF4-FFF2-40B4-BE49-F238E27FC236}">
+                <a16:creationId xmlns:a16="http://schemas.microsoft.com/office/drawing/2014/main" id="{7DFED523-207C-4513-F567-21DFCFA6310F}"/>
+              </a:ext>
+            </a:extLst>
+          </p:cNvPr>
+          <p:cNvPicPr>
+            <a:picLocks noChangeAspect="1"/>
+          </p:cNvPicPr>
+          <p:nvPr/>
+        </p:nvPicPr>
+        <p:blipFill>
+          <a:blip r:embed="rId2"/>
+          <a:stretch>
+            <a:fillRect/>
+          </a:stretch>
+        </p:blipFill>
+        <p:spPr>
+          <a:xfrm>
+            <a:off x="1818677" y="2676420"/>
+            <a:ext cx="8554644" cy="1505160"/>
+          </a:xfrm>
+          <a:prstGeom prst="rect">
+            <a:avLst/>
+          </a:prstGeom>
+        </p:spPr>
+      </p:pic>
     </p:spTree>
     <p:extLst>
       <p:ext uri="{BB962C8B-B14F-4D97-AF65-F5344CB8AC3E}">
-        <p14:creationId xmlns:p14="http://schemas.microsoft.com/office/powerpoint/2010/main" val="4233252692"/>
+        <p14:creationId xmlns:p14="http://schemas.microsoft.com/office/powerpoint/2010/main" val="525024144"/>
       </p:ext>
     </p:extLst>
   </p:cSld>
@@ -3484,6 +3588,773 @@
 </file>
 
 <file path=ppt/slides/slide3.xml><?xml version="1.0" encoding="utf-8"?>
+<p:sld xmlns:a="http://schemas.openxmlformats.org/drawingml/2006/main" xmlns:r="http://schemas.openxmlformats.org/officeDocument/2006/relationships" xmlns:p="http://schemas.openxmlformats.org/presentationml/2006/main">
+  <p:cSld>
+    <p:spTree>
+      <p:nvGrpSpPr>
+        <p:cNvPr id="1" name="">
+          <a:extLst>
+            <a:ext uri="{FF2B5EF4-FFF2-40B4-BE49-F238E27FC236}">
+              <a16:creationId xmlns:a16="http://schemas.microsoft.com/office/drawing/2014/main" id="{6A435CBA-29A4-BFD2-CEA7-3290D85ED9F8}"/>
+            </a:ext>
+          </a:extLst>
+        </p:cNvPr>
+        <p:cNvGrpSpPr/>
+        <p:nvPr/>
+      </p:nvGrpSpPr>
+      <p:grpSpPr>
+        <a:xfrm>
+          <a:off x="0" y="0"/>
+          <a:ext cx="0" cy="0"/>
+          <a:chOff x="0" y="0"/>
+          <a:chExt cx="0" cy="0"/>
+        </a:xfrm>
+      </p:grpSpPr>
+      <p:sp>
+        <p:nvSpPr>
+          <p:cNvPr id="3" name="TextBox 2">
+            <a:extLst>
+              <a:ext uri="{FF2B5EF4-FFF2-40B4-BE49-F238E27FC236}">
+                <a16:creationId xmlns:a16="http://schemas.microsoft.com/office/drawing/2014/main" id="{A727ABBC-76D0-B81B-760F-26FC272AF479}"/>
+              </a:ext>
+            </a:extLst>
+          </p:cNvPr>
+          <p:cNvSpPr txBox="1"/>
+          <p:nvPr/>
+        </p:nvSpPr>
+        <p:spPr>
+          <a:xfrm>
+            <a:off x="217714" y="255046"/>
+            <a:ext cx="11756571" cy="355354"/>
+          </a:xfrm>
+          <a:prstGeom prst="rect">
+            <a:avLst/>
+          </a:prstGeom>
+          <a:noFill/>
+        </p:spPr>
+        <p:txBody>
+          <a:bodyPr wrap="square">
+            <a:spAutoFit/>
+          </a:bodyPr>
+          <a:lstStyle/>
+          <a:p>
+            <a:pPr>
+              <a:lnSpc>
+                <a:spcPct val="150000"/>
+              </a:lnSpc>
+              <a:buNone/>
+            </a:pPr>
+            <a:r>
+              <a:rPr lang="en-US" altLang="en-US" sz="1300">
+                <a:latin typeface="Arial" panose="020B0604020202020204" pitchFamily="34" charset="0"/>
+              </a:rPr>
+              <a:t>routes\admin.php</a:t>
+            </a:r>
+            <a:endParaRPr kumimoji="0" lang="en-US" altLang="en-US" sz="1300" b="0" i="0" u="none" strike="noStrike" cap="none" normalizeH="0" baseline="0">
+              <a:ln>
+                <a:noFill/>
+              </a:ln>
+              <a:solidFill>
+                <a:schemeClr val="tx1"/>
+              </a:solidFill>
+              <a:effectLst/>
+              <a:latin typeface="Arial" panose="020B0604020202020204" pitchFamily="34" charset="0"/>
+            </a:endParaRPr>
+          </a:p>
+        </p:txBody>
+      </p:sp>
+      <p:pic>
+        <p:nvPicPr>
+          <p:cNvPr id="4" name="Picture 3">
+            <a:extLst>
+              <a:ext uri="{FF2B5EF4-FFF2-40B4-BE49-F238E27FC236}">
+                <a16:creationId xmlns:a16="http://schemas.microsoft.com/office/drawing/2014/main" id="{8F023561-3C1A-69F0-28BD-4C79E58F7DC3}"/>
+              </a:ext>
+            </a:extLst>
+          </p:cNvPr>
+          <p:cNvPicPr>
+            <a:picLocks noChangeAspect="1"/>
+          </p:cNvPicPr>
+          <p:nvPr/>
+        </p:nvPicPr>
+        <p:blipFill>
+          <a:blip r:embed="rId2"/>
+          <a:stretch>
+            <a:fillRect/>
+          </a:stretch>
+        </p:blipFill>
+        <p:spPr>
+          <a:xfrm>
+            <a:off x="-1" y="1926123"/>
+            <a:ext cx="12192000" cy="4931877"/>
+          </a:xfrm>
+          <a:prstGeom prst="rect">
+            <a:avLst/>
+          </a:prstGeom>
+        </p:spPr>
+      </p:pic>
+    </p:spTree>
+    <p:extLst>
+      <p:ext uri="{BB962C8B-B14F-4D97-AF65-F5344CB8AC3E}">
+        <p14:creationId xmlns:p14="http://schemas.microsoft.com/office/powerpoint/2010/main" val="3863838039"/>
+      </p:ext>
+    </p:extLst>
+  </p:cSld>
+  <p:clrMapOvr>
+    <a:masterClrMapping/>
+  </p:clrMapOvr>
+</p:sld>
+</file>
+
+<file path=ppt/slides/slide4.xml><?xml version="1.0" encoding="utf-8"?>
+<p:sld xmlns:a="http://schemas.openxmlformats.org/drawingml/2006/main" xmlns:r="http://schemas.openxmlformats.org/officeDocument/2006/relationships" xmlns:p="http://schemas.openxmlformats.org/presentationml/2006/main">
+  <p:cSld>
+    <p:spTree>
+      <p:nvGrpSpPr>
+        <p:cNvPr id="1" name="">
+          <a:extLst>
+            <a:ext uri="{FF2B5EF4-FFF2-40B4-BE49-F238E27FC236}">
+              <a16:creationId xmlns:a16="http://schemas.microsoft.com/office/drawing/2014/main" id="{E27C4432-347C-6F08-1CAC-51BCFCF24374}"/>
+            </a:ext>
+          </a:extLst>
+        </p:cNvPr>
+        <p:cNvGrpSpPr/>
+        <p:nvPr/>
+      </p:nvGrpSpPr>
+      <p:grpSpPr>
+        <a:xfrm>
+          <a:off x="0" y="0"/>
+          <a:ext cx="0" cy="0"/>
+          <a:chOff x="0" y="0"/>
+          <a:chExt cx="0" cy="0"/>
+        </a:xfrm>
+      </p:grpSpPr>
+      <p:sp>
+        <p:nvSpPr>
+          <p:cNvPr id="3" name="TextBox 2">
+            <a:extLst>
+              <a:ext uri="{FF2B5EF4-FFF2-40B4-BE49-F238E27FC236}">
+                <a16:creationId xmlns:a16="http://schemas.microsoft.com/office/drawing/2014/main" id="{DD03E563-80D2-6010-44B8-EE75076EB7EA}"/>
+              </a:ext>
+            </a:extLst>
+          </p:cNvPr>
+          <p:cNvSpPr txBox="1"/>
+          <p:nvPr/>
+        </p:nvSpPr>
+        <p:spPr>
+          <a:xfrm>
+            <a:off x="217714" y="255046"/>
+            <a:ext cx="11756571" cy="355354"/>
+          </a:xfrm>
+          <a:prstGeom prst="rect">
+            <a:avLst/>
+          </a:prstGeom>
+          <a:noFill/>
+        </p:spPr>
+        <p:txBody>
+          <a:bodyPr wrap="square">
+            <a:spAutoFit/>
+          </a:bodyPr>
+          <a:lstStyle/>
+          <a:p>
+            <a:pPr>
+              <a:lnSpc>
+                <a:spcPct val="150000"/>
+              </a:lnSpc>
+              <a:buNone/>
+            </a:pPr>
+            <a:r>
+              <a:rPr kumimoji="0" lang="en-US" altLang="en-US" sz="1300" b="0" i="0" u="none" strike="noStrike" cap="none" normalizeH="0" baseline="0">
+                <a:ln>
+                  <a:noFill/>
+                </a:ln>
+                <a:solidFill>
+                  <a:schemeClr val="tx1"/>
+                </a:solidFill>
+                <a:effectLst/>
+                <a:latin typeface="Arial" panose="020B0604020202020204" pitchFamily="34" charset="0"/>
+              </a:rPr>
+              <a:t>.</a:t>
+            </a:r>
+          </a:p>
+        </p:txBody>
+      </p:sp>
+      <p:pic>
+        <p:nvPicPr>
+          <p:cNvPr id="4" name="Picture 3">
+            <a:extLst>
+              <a:ext uri="{FF2B5EF4-FFF2-40B4-BE49-F238E27FC236}">
+                <a16:creationId xmlns:a16="http://schemas.microsoft.com/office/drawing/2014/main" id="{AC281C2E-9F6A-E358-58BD-C0E70221B121}"/>
+              </a:ext>
+            </a:extLst>
+          </p:cNvPr>
+          <p:cNvPicPr>
+            <a:picLocks noChangeAspect="1"/>
+          </p:cNvPicPr>
+          <p:nvPr/>
+        </p:nvPicPr>
+        <p:blipFill>
+          <a:blip r:embed="rId2"/>
+          <a:stretch>
+            <a:fillRect/>
+          </a:stretch>
+        </p:blipFill>
+        <p:spPr>
+          <a:xfrm>
+            <a:off x="9709327" y="0"/>
+            <a:ext cx="2482673" cy="6858000"/>
+          </a:xfrm>
+          <a:prstGeom prst="rect">
+            <a:avLst/>
+          </a:prstGeom>
+        </p:spPr>
+      </p:pic>
+    </p:spTree>
+    <p:extLst>
+      <p:ext uri="{BB962C8B-B14F-4D97-AF65-F5344CB8AC3E}">
+        <p14:creationId xmlns:p14="http://schemas.microsoft.com/office/powerpoint/2010/main" val="693772308"/>
+      </p:ext>
+    </p:extLst>
+  </p:cSld>
+  <p:clrMapOvr>
+    <a:masterClrMapping/>
+  </p:clrMapOvr>
+</p:sld>
+</file>
+
+<file path=ppt/slides/slide5.xml><?xml version="1.0" encoding="utf-8"?>
+<p:sld xmlns:a="http://schemas.openxmlformats.org/drawingml/2006/main" xmlns:r="http://schemas.openxmlformats.org/officeDocument/2006/relationships" xmlns:p="http://schemas.openxmlformats.org/presentationml/2006/main">
+  <p:cSld>
+    <p:spTree>
+      <p:nvGrpSpPr>
+        <p:cNvPr id="1" name="">
+          <a:extLst>
+            <a:ext uri="{FF2B5EF4-FFF2-40B4-BE49-F238E27FC236}">
+              <a16:creationId xmlns:a16="http://schemas.microsoft.com/office/drawing/2014/main" id="{761CFACA-DBF4-F2C4-600C-2D80F6293CF5}"/>
+            </a:ext>
+          </a:extLst>
+        </p:cNvPr>
+        <p:cNvGrpSpPr/>
+        <p:nvPr/>
+      </p:nvGrpSpPr>
+      <p:grpSpPr>
+        <a:xfrm>
+          <a:off x="0" y="0"/>
+          <a:ext cx="0" cy="0"/>
+          <a:chOff x="0" y="0"/>
+          <a:chExt cx="0" cy="0"/>
+        </a:xfrm>
+      </p:grpSpPr>
+      <p:sp>
+        <p:nvSpPr>
+          <p:cNvPr id="3" name="TextBox 2">
+            <a:extLst>
+              <a:ext uri="{FF2B5EF4-FFF2-40B4-BE49-F238E27FC236}">
+                <a16:creationId xmlns:a16="http://schemas.microsoft.com/office/drawing/2014/main" id="{6F419EEF-C883-6176-EE03-2B08CF26C4DD}"/>
+              </a:ext>
+            </a:extLst>
+          </p:cNvPr>
+          <p:cNvSpPr txBox="1"/>
+          <p:nvPr/>
+        </p:nvSpPr>
+        <p:spPr>
+          <a:xfrm>
+            <a:off x="217714" y="255046"/>
+            <a:ext cx="11756571" cy="2566536"/>
+          </a:xfrm>
+          <a:prstGeom prst="rect">
+            <a:avLst/>
+          </a:prstGeom>
+          <a:noFill/>
+        </p:spPr>
+        <p:txBody>
+          <a:bodyPr wrap="square">
+            <a:spAutoFit/>
+          </a:bodyPr>
+          <a:lstStyle/>
+          <a:p>
+            <a:pPr>
+              <a:lnSpc>
+                <a:spcPct val="150000"/>
+              </a:lnSpc>
+              <a:buNone/>
+            </a:pPr>
+            <a:r>
+              <a:rPr lang="en-US" altLang="en-US" sz="1100" i="1">
+                <a:latin typeface="Arial" panose="020B0604020202020204" pitchFamily="34" charset="0"/>
+              </a:rPr>
+              <a:t>app\DataTables\</a:t>
+            </a:r>
+            <a:r>
+              <a:rPr lang="en-US" altLang="en-US" sz="1100" b="1" i="1">
+                <a:latin typeface="Arial" panose="020B0604020202020204" pitchFamily="34" charset="0"/>
+              </a:rPr>
+              <a:t>ProductVariantDataTable</a:t>
+            </a:r>
+            <a:r>
+              <a:rPr lang="en-US" altLang="en-US" sz="1100" i="1">
+                <a:latin typeface="Arial" panose="020B0604020202020204" pitchFamily="34" charset="0"/>
+              </a:rPr>
+              <a:t>.php</a:t>
+            </a:r>
+            <a:r>
+              <a:rPr lang="az-Latn-AZ" altLang="en-US" sz="1100" i="1">
+                <a:latin typeface="Arial" panose="020B0604020202020204" pitchFamily="34" charset="0"/>
+              </a:rPr>
+              <a:t> - bu faylda dəyişiklik etmişik.</a:t>
+            </a:r>
+          </a:p>
+          <a:p>
+            <a:pPr>
+              <a:lnSpc>
+                <a:spcPct val="150000"/>
+              </a:lnSpc>
+              <a:buNone/>
+            </a:pPr>
+            <a:endParaRPr kumimoji="0" lang="az-Latn-AZ" altLang="en-US" sz="1100" b="0" i="0" u="none" strike="noStrike" cap="none" normalizeH="0" baseline="0">
+              <a:ln>
+                <a:noFill/>
+              </a:ln>
+              <a:solidFill>
+                <a:schemeClr val="tx1"/>
+              </a:solidFill>
+              <a:effectLst/>
+              <a:latin typeface="Arial" panose="020B0604020202020204" pitchFamily="34" charset="0"/>
+            </a:endParaRPr>
+          </a:p>
+          <a:p>
+            <a:pPr marL="285750" indent="-285750">
+              <a:buFont typeface="Wingdings" panose="05000000000000000000" pitchFamily="2" charset="2"/>
+              <a:buChar char="q"/>
+            </a:pPr>
+            <a:r>
+              <a:rPr lang="en-US" sz="1400" b="1">
+                <a:solidFill>
+                  <a:srgbClr val="FF0000"/>
+                </a:solidFill>
+              </a:rPr>
+              <a:t>productId</a:t>
+            </a:r>
+            <a:r>
+              <a:rPr lang="en-US" sz="1400"/>
+              <a:t>: Bu parametr əsasən məhsulun </a:t>
+            </a:r>
+            <a:r>
+              <a:rPr lang="en-US" sz="1400" b="1"/>
+              <a:t>ID</a:t>
+            </a:r>
+            <a:r>
+              <a:rPr lang="en-US" sz="1400"/>
+              <a:t>-sini göstərir. Yəni, bu route </a:t>
+            </a:r>
+            <a:r>
+              <a:rPr lang="en-US" sz="1400" b="1"/>
+              <a:t>products-variant-item</a:t>
+            </a:r>
+            <a:r>
+              <a:rPr lang="en-US" sz="1400"/>
+              <a:t> səhifəsinə gedərkən, hansı </a:t>
+            </a:r>
+            <a:r>
+              <a:rPr lang="en-US" sz="1400" b="1"/>
+              <a:t>məhsulun</a:t>
+            </a:r>
+            <a:r>
+              <a:rPr lang="en-US" sz="1400"/>
+              <a:t> variantları ilə əlaqəli əməliyyatlar aparılacağını bilmək üçün istifadə olunur. Məsələn, bir məhsulun müxtəlif variantlarının (rəng, ölçü, qiymət və s.) idarə olunması məqsədilə istifadə olunur.</a:t>
+            </a:r>
+          </a:p>
+          <a:p>
+            <a:br>
+              <a:rPr lang="en-US" sz="1400"/>
+            </a:br>
+            <a:endParaRPr lang="en-US" sz="1400"/>
+          </a:p>
+          <a:p>
+            <a:pPr marL="285750" indent="-285750">
+              <a:buFont typeface="Wingdings" panose="05000000000000000000" pitchFamily="2" charset="2"/>
+              <a:buChar char="q"/>
+            </a:pPr>
+            <a:r>
+              <a:rPr lang="en-US" sz="1400" b="1">
+                <a:solidFill>
+                  <a:srgbClr val="FF0000"/>
+                </a:solidFill>
+              </a:rPr>
+              <a:t>variantId</a:t>
+            </a:r>
+            <a:r>
+              <a:rPr lang="en-US" sz="1400"/>
+              <a:t>: Bu parametr isə məhsulun müəyyən bir </a:t>
+            </a:r>
+            <a:r>
+              <a:rPr lang="en-US" sz="1400" b="1"/>
+              <a:t>variantının</a:t>
+            </a:r>
+            <a:r>
+              <a:rPr lang="en-US" sz="1400"/>
+              <a:t> ID-sini göstərir. Hər bir məhsulun bir neçə fərqli variantı ola bilər (məsələn, bir məhsulun fərqli rənglərdə və ölçülərdə versiyaları). Bu route ilə </a:t>
+            </a:r>
+            <a:r>
+              <a:rPr lang="en-US" sz="1400" b="1"/>
+              <a:t>müəyyən bir məhsulun </a:t>
+            </a:r>
+            <a:r>
+              <a:rPr lang="en-US" sz="1400" b="1" i="1"/>
+              <a:t>konkret bir variantı </a:t>
+            </a:r>
+            <a:r>
+              <a:rPr lang="en-US" sz="1400"/>
+              <a:t>ilə əlaqədar əməliyyatlar (məsələn, variant item-ləri göstərmək, əlavə etmək, silmək və s.) aparılacaq.</a:t>
+            </a:r>
+          </a:p>
+          <a:p>
+            <a:pPr>
+              <a:lnSpc>
+                <a:spcPct val="150000"/>
+              </a:lnSpc>
+              <a:buNone/>
+            </a:pPr>
+            <a:endParaRPr kumimoji="0" lang="en-US" altLang="en-US" sz="1100" b="0" i="0" u="none" strike="noStrike" cap="none" normalizeH="0" baseline="0">
+              <a:ln>
+                <a:noFill/>
+              </a:ln>
+              <a:solidFill>
+                <a:schemeClr val="tx1"/>
+              </a:solidFill>
+              <a:effectLst/>
+              <a:latin typeface="Arial" panose="020B0604020202020204" pitchFamily="34" charset="0"/>
+            </a:endParaRPr>
+          </a:p>
+        </p:txBody>
+      </p:sp>
+      <p:pic>
+        <p:nvPicPr>
+          <p:cNvPr id="4" name="Picture 3">
+            <a:extLst>
+              <a:ext uri="{FF2B5EF4-FFF2-40B4-BE49-F238E27FC236}">
+                <a16:creationId xmlns:a16="http://schemas.microsoft.com/office/drawing/2014/main" id="{CF56EEA3-93BF-A5D5-8EF5-2ED85FEB92C1}"/>
+              </a:ext>
+            </a:extLst>
+          </p:cNvPr>
+          <p:cNvPicPr>
+            <a:picLocks noChangeAspect="1"/>
+          </p:cNvPicPr>
+          <p:nvPr/>
+        </p:nvPicPr>
+        <p:blipFill>
+          <a:blip r:embed="rId2"/>
+          <a:stretch>
+            <a:fillRect/>
+          </a:stretch>
+        </p:blipFill>
+        <p:spPr>
+          <a:xfrm>
+            <a:off x="5412508" y="2585755"/>
+            <a:ext cx="6779491" cy="4272244"/>
+          </a:xfrm>
+          <a:prstGeom prst="rect">
+            <a:avLst/>
+          </a:prstGeom>
+        </p:spPr>
+      </p:pic>
+      <p:sp>
+        <p:nvSpPr>
+          <p:cNvPr id="7" name="TextBox 6">
+            <a:extLst>
+              <a:ext uri="{FF2B5EF4-FFF2-40B4-BE49-F238E27FC236}">
+                <a16:creationId xmlns:a16="http://schemas.microsoft.com/office/drawing/2014/main" id="{FDE7D914-C467-CA80-C59F-16F2EE93B2F4}"/>
+              </a:ext>
+            </a:extLst>
+          </p:cNvPr>
+          <p:cNvSpPr txBox="1"/>
+          <p:nvPr/>
+        </p:nvSpPr>
+        <p:spPr>
+          <a:xfrm>
+            <a:off x="217713" y="3159256"/>
+            <a:ext cx="4991595" cy="1448730"/>
+          </a:xfrm>
+          <a:prstGeom prst="rect">
+            <a:avLst/>
+          </a:prstGeom>
+          <a:noFill/>
+        </p:spPr>
+        <p:txBody>
+          <a:bodyPr wrap="square">
+            <a:spAutoFit/>
+          </a:bodyPr>
+          <a:lstStyle/>
+          <a:p>
+            <a:pPr>
+              <a:lnSpc>
+                <a:spcPct val="150000"/>
+              </a:lnSpc>
+            </a:pPr>
+            <a:r>
+              <a:rPr lang="en-US" sz="1200" b="1">
+                <a:latin typeface="Courier New" panose="02070309020205020404" pitchFamily="49" charset="0"/>
+              </a:rPr>
+              <a:t>ProductVariantItemController</a:t>
+            </a:r>
+            <a:r>
+              <a:rPr lang="en-US" sz="1200"/>
+              <a:t>-in </a:t>
+            </a:r>
+            <a:r>
+              <a:rPr lang="en-US" sz="1200" b="1">
+                <a:solidFill>
+                  <a:srgbClr val="FF0000"/>
+                </a:solidFill>
+                <a:latin typeface="Courier New" panose="02070309020205020404" pitchFamily="49" charset="0"/>
+              </a:rPr>
+              <a:t>index</a:t>
+            </a:r>
+            <a:r>
+              <a:rPr lang="en-US" sz="1200"/>
+              <a:t> metoduna iki parametr göndərir: </a:t>
+            </a:r>
+            <a:r>
+              <a:rPr lang="en-US" sz="1200" b="1">
+                <a:solidFill>
+                  <a:srgbClr val="00B050"/>
+                </a:solidFill>
+                <a:latin typeface="Courier New" panose="02070309020205020404" pitchFamily="49" charset="0"/>
+              </a:rPr>
+              <a:t>productId</a:t>
+            </a:r>
+            <a:r>
+              <a:rPr lang="en-US" sz="1200"/>
+              <a:t> və </a:t>
+            </a:r>
+            <a:r>
+              <a:rPr lang="en-US" sz="1200" b="1">
+                <a:solidFill>
+                  <a:srgbClr val="0070C0"/>
+                </a:solidFill>
+                <a:latin typeface="Courier New" panose="02070309020205020404" pitchFamily="49" charset="0"/>
+              </a:rPr>
+              <a:t>variantId</a:t>
+            </a:r>
+            <a:r>
+              <a:rPr lang="en-US" sz="1200"/>
+              <a:t>. Bu da o deməkdir ki, həmin </a:t>
+            </a:r>
+            <a:r>
+              <a:rPr lang="en-US" sz="1200" b="1"/>
+              <a:t>metod</a:t>
+            </a:r>
+            <a:r>
+              <a:rPr lang="en-US" sz="1200"/>
+              <a:t> bu </a:t>
+            </a:r>
+            <a:r>
+              <a:rPr lang="en-US" sz="1200" b="1" i="1"/>
+              <a:t>iki parametri alır</a:t>
+            </a:r>
+            <a:r>
+              <a:rPr lang="en-US" sz="1200" i="1"/>
+              <a:t> </a:t>
+            </a:r>
+            <a:r>
+              <a:rPr lang="en-US" sz="1200"/>
+              <a:t>və sonra konkret olaraq müəyyən məhsulun müəyyən variantına </a:t>
+            </a:r>
+            <a:r>
+              <a:rPr lang="en-US" sz="1200" b="1"/>
+              <a:t>aid variant item</a:t>
+            </a:r>
+            <a:r>
+              <a:rPr lang="en-US" sz="1200"/>
+              <a:t>-l</a:t>
+            </a:r>
+            <a:r>
+              <a:rPr lang="az-Latn-AZ" sz="1200"/>
+              <a:t>a</a:t>
+            </a:r>
+            <a:r>
+              <a:rPr lang="en-US" sz="1200"/>
+              <a:t>r</a:t>
+            </a:r>
+            <a:r>
+              <a:rPr lang="az-Latn-AZ" sz="1200"/>
+              <a:t>ı</a:t>
+            </a:r>
+            <a:r>
+              <a:rPr lang="en-US" sz="1200"/>
+              <a:t> və ya əlaqədar məlumatları əldə etmək və göstərmək üçün istifadə edir.</a:t>
+            </a:r>
+          </a:p>
+        </p:txBody>
+      </p:sp>
+    </p:spTree>
+    <p:extLst>
+      <p:ext uri="{BB962C8B-B14F-4D97-AF65-F5344CB8AC3E}">
+        <p14:creationId xmlns:p14="http://schemas.microsoft.com/office/powerpoint/2010/main" val="1537478202"/>
+      </p:ext>
+    </p:extLst>
+  </p:cSld>
+  <p:clrMapOvr>
+    <a:masterClrMapping/>
+  </p:clrMapOvr>
+</p:sld>
+</file>
+
+<file path=ppt/slides/slide6.xml><?xml version="1.0" encoding="utf-8"?>
+<p:sld xmlns:a="http://schemas.openxmlformats.org/drawingml/2006/main" xmlns:r="http://schemas.openxmlformats.org/officeDocument/2006/relationships" xmlns:p="http://schemas.openxmlformats.org/presentationml/2006/main">
+  <p:cSld>
+    <p:spTree>
+      <p:nvGrpSpPr>
+        <p:cNvPr id="1" name="">
+          <a:extLst>
+            <a:ext uri="{FF2B5EF4-FFF2-40B4-BE49-F238E27FC236}">
+              <a16:creationId xmlns:a16="http://schemas.microsoft.com/office/drawing/2014/main" id="{6B19FFCE-8F52-0AF1-106D-FC52F043D02B}"/>
+            </a:ext>
+          </a:extLst>
+        </p:cNvPr>
+        <p:cNvGrpSpPr/>
+        <p:nvPr/>
+      </p:nvGrpSpPr>
+      <p:grpSpPr>
+        <a:xfrm>
+          <a:off x="0" y="0"/>
+          <a:ext cx="0" cy="0"/>
+          <a:chOff x="0" y="0"/>
+          <a:chExt cx="0" cy="0"/>
+        </a:xfrm>
+      </p:grpSpPr>
+      <p:sp>
+        <p:nvSpPr>
+          <p:cNvPr id="3" name="TextBox 2">
+            <a:extLst>
+              <a:ext uri="{FF2B5EF4-FFF2-40B4-BE49-F238E27FC236}">
+                <a16:creationId xmlns:a16="http://schemas.microsoft.com/office/drawing/2014/main" id="{67127073-B7C5-CADC-B508-0B4DB6B3F9DE}"/>
+              </a:ext>
+            </a:extLst>
+          </p:cNvPr>
+          <p:cNvSpPr txBox="1"/>
+          <p:nvPr/>
+        </p:nvSpPr>
+        <p:spPr>
+          <a:xfrm>
+            <a:off x="217714" y="255046"/>
+            <a:ext cx="11756571" cy="955518"/>
+          </a:xfrm>
+          <a:prstGeom prst="rect">
+            <a:avLst/>
+          </a:prstGeom>
+          <a:noFill/>
+        </p:spPr>
+        <p:txBody>
+          <a:bodyPr wrap="square">
+            <a:spAutoFit/>
+          </a:bodyPr>
+          <a:lstStyle/>
+          <a:p>
+            <a:pPr>
+              <a:lnSpc>
+                <a:spcPct val="150000"/>
+              </a:lnSpc>
+              <a:buNone/>
+            </a:pPr>
+            <a:r>
+              <a:rPr lang="en-US" altLang="en-US" sz="1300">
+                <a:latin typeface="Arial" panose="020B0604020202020204" pitchFamily="34" charset="0"/>
+              </a:rPr>
+              <a:t>app\Http\Controllers\Backend\ProductVariantItemController.php</a:t>
+            </a:r>
+            <a:endParaRPr lang="az-Latn-AZ" altLang="en-US" sz="1300">
+              <a:latin typeface="Arial" panose="020B0604020202020204" pitchFamily="34" charset="0"/>
+            </a:endParaRPr>
+          </a:p>
+          <a:p>
+            <a:pPr>
+              <a:lnSpc>
+                <a:spcPct val="150000"/>
+              </a:lnSpc>
+              <a:buNone/>
+            </a:pPr>
+            <a:endParaRPr kumimoji="0" lang="az-Latn-AZ" altLang="en-US" sz="1300" b="0" i="0" u="none" strike="noStrike" cap="none" normalizeH="0" baseline="0">
+              <a:ln>
+                <a:noFill/>
+              </a:ln>
+              <a:solidFill>
+                <a:schemeClr val="tx1"/>
+              </a:solidFill>
+              <a:effectLst/>
+              <a:latin typeface="Arial" panose="020B0604020202020204" pitchFamily="34" charset="0"/>
+            </a:endParaRPr>
+          </a:p>
+          <a:p>
+            <a:pPr>
+              <a:lnSpc>
+                <a:spcPct val="150000"/>
+              </a:lnSpc>
+              <a:buNone/>
+            </a:pPr>
+            <a:r>
+              <a:rPr lang="en-US" altLang="en-US" sz="1300">
+                <a:latin typeface="Arial" panose="020B0604020202020204" pitchFamily="34" charset="0"/>
+              </a:rPr>
+              <a:t>resources\views\admin\product\product-variant-item\index.blade.php</a:t>
+            </a:r>
+            <a:endParaRPr kumimoji="0" lang="en-US" altLang="en-US" sz="1300" b="0" i="0" u="none" strike="noStrike" cap="none" normalizeH="0" baseline="0">
+              <a:ln>
+                <a:noFill/>
+              </a:ln>
+              <a:solidFill>
+                <a:schemeClr val="tx1"/>
+              </a:solidFill>
+              <a:effectLst/>
+              <a:latin typeface="Arial" panose="020B0604020202020204" pitchFamily="34" charset="0"/>
+            </a:endParaRPr>
+          </a:p>
+        </p:txBody>
+      </p:sp>
+      <p:pic>
+        <p:nvPicPr>
+          <p:cNvPr id="4" name="Picture 3">
+            <a:extLst>
+              <a:ext uri="{FF2B5EF4-FFF2-40B4-BE49-F238E27FC236}">
+                <a16:creationId xmlns:a16="http://schemas.microsoft.com/office/drawing/2014/main" id="{6F39E594-9BFE-9558-A975-56DCE15D558C}"/>
+              </a:ext>
+            </a:extLst>
+          </p:cNvPr>
+          <p:cNvPicPr>
+            <a:picLocks noChangeAspect="1"/>
+          </p:cNvPicPr>
+          <p:nvPr/>
+        </p:nvPicPr>
+        <p:blipFill>
+          <a:blip r:embed="rId2"/>
+          <a:stretch>
+            <a:fillRect/>
+          </a:stretch>
+        </p:blipFill>
+        <p:spPr>
+          <a:xfrm>
+            <a:off x="2058723" y="1459345"/>
+            <a:ext cx="10133276" cy="5398655"/>
+          </a:xfrm>
+          <a:prstGeom prst="rect">
+            <a:avLst/>
+          </a:prstGeom>
+        </p:spPr>
+      </p:pic>
+    </p:spTree>
+    <p:extLst>
+      <p:ext uri="{BB962C8B-B14F-4D97-AF65-F5344CB8AC3E}">
+        <p14:creationId xmlns:p14="http://schemas.microsoft.com/office/powerpoint/2010/main" val="2800501887"/>
+      </p:ext>
+    </p:extLst>
+  </p:cSld>
+  <p:clrMapOvr>
+    <a:masterClrMapping/>
+  </p:clrMapOvr>
+</p:sld>
+</file>
+
+<file path=ppt/slides/slide7.xml><?xml version="1.0" encoding="utf-8"?>
 <p:sld xmlns:a="http://schemas.openxmlformats.org/drawingml/2006/main" xmlns:r="http://schemas.openxmlformats.org/officeDocument/2006/relationships" xmlns:p="http://schemas.openxmlformats.org/presentationml/2006/main">
   <p:cSld>
     <p:spTree>
@@ -3560,6 +4431,178 @@
     <p:extLst>
       <p:ext uri="{BB962C8B-B14F-4D97-AF65-F5344CB8AC3E}">
         <p14:creationId xmlns:p14="http://schemas.microsoft.com/office/powerpoint/2010/main" val="3095838342"/>
+      </p:ext>
+    </p:extLst>
+  </p:cSld>
+  <p:clrMapOvr>
+    <a:masterClrMapping/>
+  </p:clrMapOvr>
+</p:sld>
+</file>
+
+<file path=ppt/slides/slide8.xml><?xml version="1.0" encoding="utf-8"?>
+<p:sld xmlns:a="http://schemas.openxmlformats.org/drawingml/2006/main" xmlns:r="http://schemas.openxmlformats.org/officeDocument/2006/relationships" xmlns:p="http://schemas.openxmlformats.org/presentationml/2006/main">
+  <p:cSld>
+    <p:spTree>
+      <p:nvGrpSpPr>
+        <p:cNvPr id="1" name="">
+          <a:extLst>
+            <a:ext uri="{FF2B5EF4-FFF2-40B4-BE49-F238E27FC236}">
+              <a16:creationId xmlns:a16="http://schemas.microsoft.com/office/drawing/2014/main" id="{829BD702-6621-8E81-B1AB-E8E690632884}"/>
+            </a:ext>
+          </a:extLst>
+        </p:cNvPr>
+        <p:cNvGrpSpPr/>
+        <p:nvPr/>
+      </p:nvGrpSpPr>
+      <p:grpSpPr>
+        <a:xfrm>
+          <a:off x="0" y="0"/>
+          <a:ext cx="0" cy="0"/>
+          <a:chOff x="0" y="0"/>
+          <a:chExt cx="0" cy="0"/>
+        </a:xfrm>
+      </p:grpSpPr>
+      <p:sp>
+        <p:nvSpPr>
+          <p:cNvPr id="3" name="TextBox 2">
+            <a:extLst>
+              <a:ext uri="{FF2B5EF4-FFF2-40B4-BE49-F238E27FC236}">
+                <a16:creationId xmlns:a16="http://schemas.microsoft.com/office/drawing/2014/main" id="{A2BCA07D-5159-D4C1-00EA-038F39F0432A}"/>
+              </a:ext>
+            </a:extLst>
+          </p:cNvPr>
+          <p:cNvSpPr txBox="1"/>
+          <p:nvPr/>
+        </p:nvSpPr>
+        <p:spPr>
+          <a:xfrm>
+            <a:off x="217714" y="255046"/>
+            <a:ext cx="11756571" cy="355354"/>
+          </a:xfrm>
+          <a:prstGeom prst="rect">
+            <a:avLst/>
+          </a:prstGeom>
+          <a:noFill/>
+        </p:spPr>
+        <p:txBody>
+          <a:bodyPr wrap="square">
+            <a:spAutoFit/>
+          </a:bodyPr>
+          <a:lstStyle/>
+          <a:p>
+            <a:pPr>
+              <a:lnSpc>
+                <a:spcPct val="150000"/>
+              </a:lnSpc>
+              <a:buNone/>
+            </a:pPr>
+            <a:r>
+              <a:rPr kumimoji="0" lang="en-US" altLang="en-US" sz="1300" b="0" i="0" u="none" strike="noStrike" cap="none" normalizeH="0" baseline="0">
+                <a:ln>
+                  <a:noFill/>
+                </a:ln>
+                <a:solidFill>
+                  <a:schemeClr val="tx1"/>
+                </a:solidFill>
+                <a:effectLst/>
+                <a:latin typeface="Arial" panose="020B0604020202020204" pitchFamily="34" charset="0"/>
+              </a:rPr>
+              <a:t>.</a:t>
+            </a:r>
+          </a:p>
+        </p:txBody>
+      </p:sp>
+    </p:spTree>
+    <p:extLst>
+      <p:ext uri="{BB962C8B-B14F-4D97-AF65-F5344CB8AC3E}">
+        <p14:creationId xmlns:p14="http://schemas.microsoft.com/office/powerpoint/2010/main" val="3213628664"/>
+      </p:ext>
+    </p:extLst>
+  </p:cSld>
+  <p:clrMapOvr>
+    <a:masterClrMapping/>
+  </p:clrMapOvr>
+</p:sld>
+</file>
+
+<file path=ppt/slides/slide9.xml><?xml version="1.0" encoding="utf-8"?>
+<p:sld xmlns:a="http://schemas.openxmlformats.org/drawingml/2006/main" xmlns:r="http://schemas.openxmlformats.org/officeDocument/2006/relationships" xmlns:p="http://schemas.openxmlformats.org/presentationml/2006/main">
+  <p:cSld>
+    <p:spTree>
+      <p:nvGrpSpPr>
+        <p:cNvPr id="1" name="">
+          <a:extLst>
+            <a:ext uri="{FF2B5EF4-FFF2-40B4-BE49-F238E27FC236}">
+              <a16:creationId xmlns:a16="http://schemas.microsoft.com/office/drawing/2014/main" id="{AACF4908-C7F8-4A39-BD89-7C5A0DFED8A8}"/>
+            </a:ext>
+          </a:extLst>
+        </p:cNvPr>
+        <p:cNvGrpSpPr/>
+        <p:nvPr/>
+      </p:nvGrpSpPr>
+      <p:grpSpPr>
+        <a:xfrm>
+          <a:off x="0" y="0"/>
+          <a:ext cx="0" cy="0"/>
+          <a:chOff x="0" y="0"/>
+          <a:chExt cx="0" cy="0"/>
+        </a:xfrm>
+      </p:grpSpPr>
+      <p:sp>
+        <p:nvSpPr>
+          <p:cNvPr id="3" name="TextBox 2">
+            <a:extLst>
+              <a:ext uri="{FF2B5EF4-FFF2-40B4-BE49-F238E27FC236}">
+                <a16:creationId xmlns:a16="http://schemas.microsoft.com/office/drawing/2014/main" id="{563926EE-C5BC-68C1-0A2D-3CEF5FE55CBB}"/>
+              </a:ext>
+            </a:extLst>
+          </p:cNvPr>
+          <p:cNvSpPr txBox="1"/>
+          <p:nvPr/>
+        </p:nvSpPr>
+        <p:spPr>
+          <a:xfrm>
+            <a:off x="217714" y="255046"/>
+            <a:ext cx="11756571" cy="355354"/>
+          </a:xfrm>
+          <a:prstGeom prst="rect">
+            <a:avLst/>
+          </a:prstGeom>
+          <a:noFill/>
+        </p:spPr>
+        <p:txBody>
+          <a:bodyPr wrap="square">
+            <a:spAutoFit/>
+          </a:bodyPr>
+          <a:lstStyle/>
+          <a:p>
+            <a:pPr>
+              <a:lnSpc>
+                <a:spcPct val="150000"/>
+              </a:lnSpc>
+              <a:buNone/>
+            </a:pPr>
+            <a:r>
+              <a:rPr kumimoji="0" lang="en-US" altLang="en-US" sz="1300" b="0" i="0" u="none" strike="noStrike" cap="none" normalizeH="0" baseline="0">
+                <a:ln>
+                  <a:noFill/>
+                </a:ln>
+                <a:solidFill>
+                  <a:schemeClr val="tx1"/>
+                </a:solidFill>
+                <a:effectLst/>
+                <a:latin typeface="Arial" panose="020B0604020202020204" pitchFamily="34" charset="0"/>
+              </a:rPr>
+              <a:t>.</a:t>
+            </a:r>
+          </a:p>
+        </p:txBody>
+      </p:sp>
+    </p:spTree>
+    <p:extLst>
+      <p:ext uri="{BB962C8B-B14F-4D97-AF65-F5344CB8AC3E}">
+        <p14:creationId xmlns:p14="http://schemas.microsoft.com/office/powerpoint/2010/main" val="4118003497"/>
       </p:ext>
     </p:extLst>
   </p:cSld>

</xml_diff>

<commit_message>
Product Variant item- Show created data in datatable
</commit_message>
<xml_diff>
--- a/.lessons/58 Backend Product And Related Features/24 Product Variant Item- Create necessary files/1.pptx
+++ b/.lessons/58 Backend Product And Related Features/24 Product Variant Item- Create necessary files/1.pptx
@@ -6,15 +6,14 @@
   </p:sldMasterIdLst>
   <p:sldIdLst>
     <p:sldId id="414" r:id="rId2"/>
-    <p:sldId id="417" r:id="rId3"/>
-    <p:sldId id="413" r:id="rId4"/>
-    <p:sldId id="415" r:id="rId5"/>
-    <p:sldId id="416" r:id="rId6"/>
-    <p:sldId id="418" r:id="rId7"/>
-    <p:sldId id="400" r:id="rId8"/>
-    <p:sldId id="419" r:id="rId9"/>
-    <p:sldId id="420" r:id="rId10"/>
-    <p:sldId id="421" r:id="rId11"/>
+    <p:sldId id="413" r:id="rId3"/>
+    <p:sldId id="415" r:id="rId4"/>
+    <p:sldId id="416" r:id="rId5"/>
+    <p:sldId id="418" r:id="rId6"/>
+    <p:sldId id="400" r:id="rId7"/>
+    <p:sldId id="419" r:id="rId8"/>
+    <p:sldId id="420" r:id="rId9"/>
+    <p:sldId id="421" r:id="rId10"/>
   </p:sldIdLst>
   <p:sldSz cx="12192000" cy="6858000"/>
   <p:notesSz cx="6858000" cy="9144000"/>
@@ -3357,15 +3356,75 @@
         </p:nvPicPr>
         <p:blipFill>
           <a:blip r:embed="rId2"/>
-          <a:srcRect b="39070"/>
+          <a:srcRect t="1" b="71691"/>
           <a:stretch>
             <a:fillRect/>
           </a:stretch>
         </p:blipFill>
         <p:spPr>
           <a:xfrm>
-            <a:off x="418307" y="2482886"/>
-            <a:ext cx="11355385" cy="1892228"/>
+            <a:off x="418307" y="966662"/>
+            <a:ext cx="11355385" cy="879150"/>
+          </a:xfrm>
+          <a:prstGeom prst="rect">
+            <a:avLst/>
+          </a:prstGeom>
+        </p:spPr>
+      </p:pic>
+      <p:pic>
+        <p:nvPicPr>
+          <p:cNvPr id="3" name="Picture 2">
+            <a:extLst>
+              <a:ext uri="{FF2B5EF4-FFF2-40B4-BE49-F238E27FC236}">
+                <a16:creationId xmlns:a16="http://schemas.microsoft.com/office/drawing/2014/main" id="{ABED807D-7E5C-B55C-00A4-91F6E7129659}"/>
+              </a:ext>
+            </a:extLst>
+          </p:cNvPr>
+          <p:cNvPicPr>
+            <a:picLocks noChangeAspect="1"/>
+          </p:cNvPicPr>
+          <p:nvPr/>
+        </p:nvPicPr>
+        <p:blipFill>
+          <a:blip r:embed="rId3"/>
+          <a:stretch>
+            <a:fillRect/>
+          </a:stretch>
+        </p:blipFill>
+        <p:spPr>
+          <a:xfrm>
+            <a:off x="418307" y="2518087"/>
+            <a:ext cx="10755226" cy="2162477"/>
+          </a:xfrm>
+          <a:prstGeom prst="rect">
+            <a:avLst/>
+          </a:prstGeom>
+        </p:spPr>
+      </p:pic>
+      <p:pic>
+        <p:nvPicPr>
+          <p:cNvPr id="5" name="Picture 4">
+            <a:extLst>
+              <a:ext uri="{FF2B5EF4-FFF2-40B4-BE49-F238E27FC236}">
+                <a16:creationId xmlns:a16="http://schemas.microsoft.com/office/drawing/2014/main" id="{7DFED523-207C-4513-F567-21DFCFA6310F}"/>
+              </a:ext>
+            </a:extLst>
+          </p:cNvPr>
+          <p:cNvPicPr>
+            <a:picLocks noChangeAspect="1"/>
+          </p:cNvPicPr>
+          <p:nvPr/>
+        </p:nvPicPr>
+        <p:blipFill>
+          <a:blip r:embed="rId4"/>
+          <a:stretch>
+            <a:fillRect/>
+          </a:stretch>
+        </p:blipFill>
+        <p:spPr>
+          <a:xfrm>
+            <a:off x="418307" y="5352840"/>
+            <a:ext cx="8554644" cy="1505160"/>
           </a:xfrm>
           <a:prstGeom prst="rect">
             <a:avLst/>
@@ -3385,209 +3444,7 @@
 </p:sld>
 </file>
 
-<file path=ppt/slides/slide10.xml><?xml version="1.0" encoding="utf-8"?>
-<p:sld xmlns:a="http://schemas.openxmlformats.org/drawingml/2006/main" xmlns:r="http://schemas.openxmlformats.org/officeDocument/2006/relationships" xmlns:p="http://schemas.openxmlformats.org/presentationml/2006/main">
-  <p:cSld>
-    <p:spTree>
-      <p:nvGrpSpPr>
-        <p:cNvPr id="1" name="">
-          <a:extLst>
-            <a:ext uri="{FF2B5EF4-FFF2-40B4-BE49-F238E27FC236}">
-              <a16:creationId xmlns:a16="http://schemas.microsoft.com/office/drawing/2014/main" id="{F7400297-8013-7331-4BD5-647EEECFE1DE}"/>
-            </a:ext>
-          </a:extLst>
-        </p:cNvPr>
-        <p:cNvGrpSpPr/>
-        <p:nvPr/>
-      </p:nvGrpSpPr>
-      <p:grpSpPr>
-        <a:xfrm>
-          <a:off x="0" y="0"/>
-          <a:ext cx="0" cy="0"/>
-          <a:chOff x="0" y="0"/>
-          <a:chExt cx="0" cy="0"/>
-        </a:xfrm>
-      </p:grpSpPr>
-      <p:sp>
-        <p:nvSpPr>
-          <p:cNvPr id="3" name="TextBox 2">
-            <a:extLst>
-              <a:ext uri="{FF2B5EF4-FFF2-40B4-BE49-F238E27FC236}">
-                <a16:creationId xmlns:a16="http://schemas.microsoft.com/office/drawing/2014/main" id="{64C23C3C-4E11-719E-60D0-2D157BE2FA5F}"/>
-              </a:ext>
-            </a:extLst>
-          </p:cNvPr>
-          <p:cNvSpPr txBox="1"/>
-          <p:nvPr/>
-        </p:nvSpPr>
-        <p:spPr>
-          <a:xfrm>
-            <a:off x="217714" y="255046"/>
-            <a:ext cx="11756571" cy="355354"/>
-          </a:xfrm>
-          <a:prstGeom prst="rect">
-            <a:avLst/>
-          </a:prstGeom>
-          <a:noFill/>
-        </p:spPr>
-        <p:txBody>
-          <a:bodyPr wrap="square">
-            <a:spAutoFit/>
-          </a:bodyPr>
-          <a:lstStyle/>
-          <a:p>
-            <a:pPr>
-              <a:lnSpc>
-                <a:spcPct val="150000"/>
-              </a:lnSpc>
-              <a:buNone/>
-            </a:pPr>
-            <a:r>
-              <a:rPr kumimoji="0" lang="en-US" altLang="en-US" sz="1300" b="0" i="0" u="none" strike="noStrike" cap="none" normalizeH="0" baseline="0">
-                <a:ln>
-                  <a:noFill/>
-                </a:ln>
-                <a:solidFill>
-                  <a:schemeClr val="tx1"/>
-                </a:solidFill>
-                <a:effectLst/>
-                <a:latin typeface="Arial" panose="020B0604020202020204" pitchFamily="34" charset="0"/>
-              </a:rPr>
-              <a:t>.</a:t>
-            </a:r>
-          </a:p>
-        </p:txBody>
-      </p:sp>
-    </p:spTree>
-    <p:extLst>
-      <p:ext uri="{BB962C8B-B14F-4D97-AF65-F5344CB8AC3E}">
-        <p14:creationId xmlns:p14="http://schemas.microsoft.com/office/powerpoint/2010/main" val="2193773251"/>
-      </p:ext>
-    </p:extLst>
-  </p:cSld>
-  <p:clrMapOvr>
-    <a:masterClrMapping/>
-  </p:clrMapOvr>
-</p:sld>
-</file>
-
 <file path=ppt/slides/slide2.xml><?xml version="1.0" encoding="utf-8"?>
-<p:sld xmlns:a="http://schemas.openxmlformats.org/drawingml/2006/main" xmlns:r="http://schemas.openxmlformats.org/officeDocument/2006/relationships" xmlns:p="http://schemas.openxmlformats.org/presentationml/2006/main">
-  <p:cSld>
-    <p:spTree>
-      <p:nvGrpSpPr>
-        <p:cNvPr id="1" name="">
-          <a:extLst>
-            <a:ext uri="{FF2B5EF4-FFF2-40B4-BE49-F238E27FC236}">
-              <a16:creationId xmlns:a16="http://schemas.microsoft.com/office/drawing/2014/main" id="{84A11A67-1FE1-4531-AB26-80EEB8563AE6}"/>
-            </a:ext>
-          </a:extLst>
-        </p:cNvPr>
-        <p:cNvGrpSpPr/>
-        <p:nvPr/>
-      </p:nvGrpSpPr>
-      <p:grpSpPr>
-        <a:xfrm>
-          <a:off x="0" y="0"/>
-          <a:ext cx="0" cy="0"/>
-          <a:chOff x="0" y="0"/>
-          <a:chExt cx="0" cy="0"/>
-        </a:xfrm>
-      </p:grpSpPr>
-      <p:sp>
-        <p:nvSpPr>
-          <p:cNvPr id="3" name="TextBox 2">
-            <a:extLst>
-              <a:ext uri="{FF2B5EF4-FFF2-40B4-BE49-F238E27FC236}">
-                <a16:creationId xmlns:a16="http://schemas.microsoft.com/office/drawing/2014/main" id="{775231B5-FF9F-23DD-FC24-8DC4C695A071}"/>
-              </a:ext>
-            </a:extLst>
-          </p:cNvPr>
-          <p:cNvSpPr txBox="1"/>
-          <p:nvPr/>
-        </p:nvSpPr>
-        <p:spPr>
-          <a:xfrm>
-            <a:off x="217714" y="255046"/>
-            <a:ext cx="11756571" cy="355354"/>
-          </a:xfrm>
-          <a:prstGeom prst="rect">
-            <a:avLst/>
-          </a:prstGeom>
-          <a:noFill/>
-        </p:spPr>
-        <p:txBody>
-          <a:bodyPr wrap="square">
-            <a:spAutoFit/>
-          </a:bodyPr>
-          <a:lstStyle/>
-          <a:p>
-            <a:pPr>
-              <a:lnSpc>
-                <a:spcPct val="150000"/>
-              </a:lnSpc>
-              <a:buNone/>
-            </a:pPr>
-            <a:r>
-              <a:rPr kumimoji="0" lang="en-US" altLang="en-US" sz="1300" b="0" i="0" u="none" strike="noStrike" cap="none" normalizeH="0" baseline="0">
-                <a:ln>
-                  <a:noFill/>
-                </a:ln>
-                <a:solidFill>
-                  <a:schemeClr val="tx1"/>
-                </a:solidFill>
-                <a:effectLst/>
-                <a:latin typeface="Arial" panose="020B0604020202020204" pitchFamily="34" charset="0"/>
-              </a:rPr>
-              <a:t>.</a:t>
-            </a:r>
-          </a:p>
-        </p:txBody>
-      </p:sp>
-      <p:pic>
-        <p:nvPicPr>
-          <p:cNvPr id="4" name="Picture 3">
-            <a:extLst>
-              <a:ext uri="{FF2B5EF4-FFF2-40B4-BE49-F238E27FC236}">
-                <a16:creationId xmlns:a16="http://schemas.microsoft.com/office/drawing/2014/main" id="{7DFED523-207C-4513-F567-21DFCFA6310F}"/>
-              </a:ext>
-            </a:extLst>
-          </p:cNvPr>
-          <p:cNvPicPr>
-            <a:picLocks noChangeAspect="1"/>
-          </p:cNvPicPr>
-          <p:nvPr/>
-        </p:nvPicPr>
-        <p:blipFill>
-          <a:blip r:embed="rId2"/>
-          <a:stretch>
-            <a:fillRect/>
-          </a:stretch>
-        </p:blipFill>
-        <p:spPr>
-          <a:xfrm>
-            <a:off x="1818677" y="2676420"/>
-            <a:ext cx="8554644" cy="1505160"/>
-          </a:xfrm>
-          <a:prstGeom prst="rect">
-            <a:avLst/>
-          </a:prstGeom>
-        </p:spPr>
-      </p:pic>
-    </p:spTree>
-    <p:extLst>
-      <p:ext uri="{BB962C8B-B14F-4D97-AF65-F5344CB8AC3E}">
-        <p14:creationId xmlns:p14="http://schemas.microsoft.com/office/powerpoint/2010/main" val="525024144"/>
-      </p:ext>
-    </p:extLst>
-  </p:cSld>
-  <p:clrMapOvr>
-    <a:masterClrMapping/>
-  </p:clrMapOvr>
-</p:sld>
-</file>
-
-<file path=ppt/slides/slide3.xml><?xml version="1.0" encoding="utf-8"?>
 <p:sld xmlns:a="http://schemas.openxmlformats.org/drawingml/2006/main" xmlns:r="http://schemas.openxmlformats.org/officeDocument/2006/relationships" xmlns:p="http://schemas.openxmlformats.org/presentationml/2006/main">
   <p:cSld>
     <p:spTree>
@@ -3706,7 +3563,7 @@
 </p:sld>
 </file>
 
-<file path=ppt/slides/slide4.xml><?xml version="1.0" encoding="utf-8"?>
+<file path=ppt/slides/slide3.xml><?xml version="1.0" encoding="utf-8"?>
 <p:sld xmlns:a="http://schemas.openxmlformats.org/drawingml/2006/main" xmlns:r="http://schemas.openxmlformats.org/officeDocument/2006/relationships" xmlns:p="http://schemas.openxmlformats.org/presentationml/2006/main">
   <p:cSld>
     <p:spTree>
@@ -3822,7 +3679,7 @@
 </p:sld>
 </file>
 
-<file path=ppt/slides/slide5.xml><?xml version="1.0" encoding="utf-8"?>
+<file path=ppt/slides/slide4.xml><?xml version="1.0" encoding="utf-8"?>
 <p:sld xmlns:a="http://schemas.openxmlformats.org/drawingml/2006/main" xmlns:r="http://schemas.openxmlformats.org/officeDocument/2006/relationships" xmlns:p="http://schemas.openxmlformats.org/presentationml/2006/main">
   <p:cSld>
     <p:spTree>
@@ -4200,7 +4057,7 @@
 </p:sld>
 </file>
 
-<file path=ppt/slides/slide6.xml><?xml version="1.0" encoding="utf-8"?>
+<file path=ppt/slides/slide5.xml><?xml version="1.0" encoding="utf-8"?>
 <p:sld xmlns:a="http://schemas.openxmlformats.org/drawingml/2006/main" xmlns:r="http://schemas.openxmlformats.org/officeDocument/2006/relationships" xmlns:p="http://schemas.openxmlformats.org/presentationml/2006/main">
   <p:cSld>
     <p:spTree>
@@ -4354,7 +4211,7 @@
 </p:sld>
 </file>
 
-<file path=ppt/slides/slide7.xml><?xml version="1.0" encoding="utf-8"?>
+<file path=ppt/slides/slide6.xml><?xml version="1.0" encoding="utf-8"?>
 <p:sld xmlns:a="http://schemas.openxmlformats.org/drawingml/2006/main" xmlns:r="http://schemas.openxmlformats.org/officeDocument/2006/relationships" xmlns:p="http://schemas.openxmlformats.org/presentationml/2006/main">
   <p:cSld>
     <p:spTree>
@@ -4440,7 +4297,7 @@
 </p:sld>
 </file>
 
-<file path=ppt/slides/slide8.xml><?xml version="1.0" encoding="utf-8"?>
+<file path=ppt/slides/slide7.xml><?xml version="1.0" encoding="utf-8"?>
 <p:sld xmlns:a="http://schemas.openxmlformats.org/drawingml/2006/main" xmlns:r="http://schemas.openxmlformats.org/officeDocument/2006/relationships" xmlns:p="http://schemas.openxmlformats.org/presentationml/2006/main">
   <p:cSld>
     <p:spTree>
@@ -4526,7 +4383,7 @@
 </p:sld>
 </file>
 
-<file path=ppt/slides/slide9.xml><?xml version="1.0" encoding="utf-8"?>
+<file path=ppt/slides/slide8.xml><?xml version="1.0" encoding="utf-8"?>
 <p:sld xmlns:a="http://schemas.openxmlformats.org/drawingml/2006/main" xmlns:r="http://schemas.openxmlformats.org/officeDocument/2006/relationships" xmlns:p="http://schemas.openxmlformats.org/presentationml/2006/main">
   <p:cSld>
     <p:spTree>
@@ -4603,6 +4460,92 @@
     <p:extLst>
       <p:ext uri="{BB962C8B-B14F-4D97-AF65-F5344CB8AC3E}">
         <p14:creationId xmlns:p14="http://schemas.microsoft.com/office/powerpoint/2010/main" val="4118003497"/>
+      </p:ext>
+    </p:extLst>
+  </p:cSld>
+  <p:clrMapOvr>
+    <a:masterClrMapping/>
+  </p:clrMapOvr>
+</p:sld>
+</file>
+
+<file path=ppt/slides/slide9.xml><?xml version="1.0" encoding="utf-8"?>
+<p:sld xmlns:a="http://schemas.openxmlformats.org/drawingml/2006/main" xmlns:r="http://schemas.openxmlformats.org/officeDocument/2006/relationships" xmlns:p="http://schemas.openxmlformats.org/presentationml/2006/main">
+  <p:cSld>
+    <p:spTree>
+      <p:nvGrpSpPr>
+        <p:cNvPr id="1" name="">
+          <a:extLst>
+            <a:ext uri="{FF2B5EF4-FFF2-40B4-BE49-F238E27FC236}">
+              <a16:creationId xmlns:a16="http://schemas.microsoft.com/office/drawing/2014/main" id="{F7400297-8013-7331-4BD5-647EEECFE1DE}"/>
+            </a:ext>
+          </a:extLst>
+        </p:cNvPr>
+        <p:cNvGrpSpPr/>
+        <p:nvPr/>
+      </p:nvGrpSpPr>
+      <p:grpSpPr>
+        <a:xfrm>
+          <a:off x="0" y="0"/>
+          <a:ext cx="0" cy="0"/>
+          <a:chOff x="0" y="0"/>
+          <a:chExt cx="0" cy="0"/>
+        </a:xfrm>
+      </p:grpSpPr>
+      <p:sp>
+        <p:nvSpPr>
+          <p:cNvPr id="3" name="TextBox 2">
+            <a:extLst>
+              <a:ext uri="{FF2B5EF4-FFF2-40B4-BE49-F238E27FC236}">
+                <a16:creationId xmlns:a16="http://schemas.microsoft.com/office/drawing/2014/main" id="{64C23C3C-4E11-719E-60D0-2D157BE2FA5F}"/>
+              </a:ext>
+            </a:extLst>
+          </p:cNvPr>
+          <p:cNvSpPr txBox="1"/>
+          <p:nvPr/>
+        </p:nvSpPr>
+        <p:spPr>
+          <a:xfrm>
+            <a:off x="217714" y="255046"/>
+            <a:ext cx="11756571" cy="355354"/>
+          </a:xfrm>
+          <a:prstGeom prst="rect">
+            <a:avLst/>
+          </a:prstGeom>
+          <a:noFill/>
+        </p:spPr>
+        <p:txBody>
+          <a:bodyPr wrap="square">
+            <a:spAutoFit/>
+          </a:bodyPr>
+          <a:lstStyle/>
+          <a:p>
+            <a:pPr>
+              <a:lnSpc>
+                <a:spcPct val="150000"/>
+              </a:lnSpc>
+              <a:buNone/>
+            </a:pPr>
+            <a:r>
+              <a:rPr kumimoji="0" lang="en-US" altLang="en-US" sz="1300" b="0" i="0" u="none" strike="noStrike" cap="none" normalizeH="0" baseline="0">
+                <a:ln>
+                  <a:noFill/>
+                </a:ln>
+                <a:solidFill>
+                  <a:schemeClr val="tx1"/>
+                </a:solidFill>
+                <a:effectLst/>
+                <a:latin typeface="Arial" panose="020B0604020202020204" pitchFamily="34" charset="0"/>
+              </a:rPr>
+              <a:t>.</a:t>
+            </a:r>
+          </a:p>
+        </p:txBody>
+      </p:sp>
+    </p:spTree>
+    <p:extLst>
+      <p:ext uri="{BB962C8B-B14F-4D97-AF65-F5344CB8AC3E}">
+        <p14:creationId xmlns:p14="http://schemas.microsoft.com/office/powerpoint/2010/main" val="2193773251"/>
       </p:ext>
     </p:extLst>
   </p:cSld>

</xml_diff>